<commit_message>
finally completed learning the pub-sub model...man this was so tiring
</commit_message>
<xml_diff>
--- a/hospitalManagementSystem/PPT.pptx
+++ b/hospitalManagementSystem/PPT.pptx
@@ -308,7 +308,7 @@
             <a:fld id="{1D8BD707-D9CF-40AE-B4C6-C98DA3205C09}" type="datetimeFigureOut">
               <a:rPr lang="en-US" smtClean="0"/>
               <a:pPr/>
-              <a:t>12/20/2025</a:t>
+              <a:t>12/23/2025</a:t>
             </a:fld>
             <a:endParaRPr lang="en-US"/>
           </a:p>
@@ -475,7 +475,7 @@
             <a:fld id="{1D8BD707-D9CF-40AE-B4C6-C98DA3205C09}" type="datetimeFigureOut">
               <a:rPr lang="en-US" smtClean="0"/>
               <a:pPr/>
-              <a:t>12/20/2025</a:t>
+              <a:t>12/23/2025</a:t>
             </a:fld>
             <a:endParaRPr lang="en-US"/>
           </a:p>
@@ -652,7 +652,7 @@
             <a:fld id="{1D8BD707-D9CF-40AE-B4C6-C98DA3205C09}" type="datetimeFigureOut">
               <a:rPr lang="en-US" smtClean="0"/>
               <a:pPr/>
-              <a:t>12/20/2025</a:t>
+              <a:t>12/23/2025</a:t>
             </a:fld>
             <a:endParaRPr lang="en-US"/>
           </a:p>
@@ -819,7 +819,7 @@
             <a:fld id="{1D8BD707-D9CF-40AE-B4C6-C98DA3205C09}" type="datetimeFigureOut">
               <a:rPr lang="en-US" smtClean="0"/>
               <a:pPr/>
-              <a:t>12/20/2025</a:t>
+              <a:t>12/23/2025</a:t>
             </a:fld>
             <a:endParaRPr lang="en-US"/>
           </a:p>
@@ -1062,7 +1062,7 @@
             <a:fld id="{1D8BD707-D9CF-40AE-B4C6-C98DA3205C09}" type="datetimeFigureOut">
               <a:rPr lang="en-US" smtClean="0"/>
               <a:pPr/>
-              <a:t>12/20/2025</a:t>
+              <a:t>12/23/2025</a:t>
             </a:fld>
             <a:endParaRPr lang="en-US"/>
           </a:p>
@@ -1347,7 +1347,7 @@
             <a:fld id="{1D8BD707-D9CF-40AE-B4C6-C98DA3205C09}" type="datetimeFigureOut">
               <a:rPr lang="en-US" smtClean="0"/>
               <a:pPr/>
-              <a:t>12/20/2025</a:t>
+              <a:t>12/23/2025</a:t>
             </a:fld>
             <a:endParaRPr lang="en-US"/>
           </a:p>
@@ -1778,7 +1778,7 @@
             <a:fld id="{1D8BD707-D9CF-40AE-B4C6-C98DA3205C09}" type="datetimeFigureOut">
               <a:rPr lang="en-US" smtClean="0"/>
               <a:pPr/>
-              <a:t>12/20/2025</a:t>
+              <a:t>12/23/2025</a:t>
             </a:fld>
             <a:endParaRPr lang="en-US"/>
           </a:p>
@@ -1893,7 +1893,7 @@
             <a:fld id="{1D8BD707-D9CF-40AE-B4C6-C98DA3205C09}" type="datetimeFigureOut">
               <a:rPr lang="en-US" smtClean="0"/>
               <a:pPr/>
-              <a:t>12/20/2025</a:t>
+              <a:t>12/23/2025</a:t>
             </a:fld>
             <a:endParaRPr lang="en-US"/>
           </a:p>
@@ -1985,7 +1985,7 @@
             <a:fld id="{1D8BD707-D9CF-40AE-B4C6-C98DA3205C09}" type="datetimeFigureOut">
               <a:rPr lang="en-US" smtClean="0"/>
               <a:pPr/>
-              <a:t>12/20/2025</a:t>
+              <a:t>12/23/2025</a:t>
             </a:fld>
             <a:endParaRPr lang="en-US"/>
           </a:p>
@@ -2176,7 +2176,7 @@
             <a:fld id="{1D8BD707-D9CF-40AE-B4C6-C98DA3205C09}" type="datetimeFigureOut">
               <a:rPr lang="en-US" smtClean="0"/>
               <a:pPr/>
-              <a:t>12/20/2025</a:t>
+              <a:t>12/23/2025</a:t>
             </a:fld>
             <a:endParaRPr lang="en-US"/>
           </a:p>
@@ -2496,7 +2496,7 @@
             <a:fld id="{1D8BD707-D9CF-40AE-B4C6-C98DA3205C09}" type="datetimeFigureOut">
               <a:rPr lang="en-US" smtClean="0"/>
               <a:pPr/>
-              <a:t>12/20/2025</a:t>
+              <a:t>12/23/2025</a:t>
             </a:fld>
             <a:endParaRPr lang="en-US"/>
           </a:p>
@@ -2878,7 +2878,7 @@
             <a:fld id="{1D8BD707-D9CF-40AE-B4C6-C98DA3205C09}" type="datetimeFigureOut">
               <a:rPr lang="en-US" smtClean="0"/>
               <a:pPr/>
-              <a:t>12/20/2025</a:t>
+              <a:t>12/23/2025</a:t>
             </a:fld>
             <a:endParaRPr lang="en-US"/>
           </a:p>
@@ -3738,15 +3738,23 @@
             </a:r>
             <a:r>
               <a:rPr lang="en-IN" dirty="0"/>
-              <a:t>. Run the file: java "-</a:t>
-            </a:r>
-            <a:r>
-              <a:rPr lang="en-IN" dirty="0" err="1"/>
+              <a:t>. Run the file: java </a:t>
+            </a:r>
+            <a:r>
+              <a:rPr lang="en-IN" dirty="0" smtClean="0"/>
+              <a:t>"-</a:t>
+            </a:r>
+            <a:r>
+              <a:rPr lang="en-IN" dirty="0" err="1" smtClean="0"/>
               <a:t>Duser.timezone</a:t>
             </a:r>
             <a:r>
+              <a:rPr lang="en-IN" dirty="0" smtClean="0"/>
+              <a:t>=UTC" </a:t>
+            </a:r>
+            <a:r>
               <a:rPr lang="en-IN" dirty="0"/>
-              <a:t>=UTC" -jar target/hospitalManagementSystem-0.0.1-SNAPSHOT.jar</a:t>
+              <a:t>-jar target/hospitalManagementSystem-0.0.1-SNAPSHOT.jar</a:t>
             </a:r>
           </a:p>
         </p:txBody>

</xml_diff>